<commit_message>
feat(presentation): remediate premium deck v2
</commit_message>
<xml_diff>
--- a/presentation/premium/einfachhausen-premium.pptx
+++ b/presentation/premium/einfachhausen-premium.pptx
@@ -2123,7 +2123,7 @@
       </p:grpSpPr>
       <p:pic>
         <p:nvPicPr>
-          <p:cNvPr id="2" name="Image 0" descr="/Users/jeremy/dev/einfach-hausen/.worktrees/t0165-premium/presentation/premium/rendered/slide-01.png">    </p:cNvPr>
+          <p:cNvPr id="2" name="Image 0" descr="/home/ubuntu/dev/einfach-hausen/t0165-prime-redesign/presentation/premium/rendered/slide-01.png">    </p:cNvPr>
           <p:cNvPicPr>
             <a:picLocks noChangeAspect="1"/>
           </p:cNvPicPr>
@@ -2179,7 +2179,7 @@
       </p:grpSpPr>
       <p:pic>
         <p:nvPicPr>
-          <p:cNvPr id="2" name="Image 0" descr="/Users/jeremy/dev/einfach-hausen/.worktrees/t0165-premium/presentation/premium/rendered/slide-10.png">    </p:cNvPr>
+          <p:cNvPr id="2" name="Image 0" descr="/home/ubuntu/dev/einfach-hausen/t0165-prime-redesign/presentation/premium/rendered/slide-10.png">    </p:cNvPr>
           <p:cNvPicPr>
             <a:picLocks noChangeAspect="1"/>
           </p:cNvPicPr>
@@ -2235,7 +2235,7 @@
       </p:grpSpPr>
       <p:pic>
         <p:nvPicPr>
-          <p:cNvPr id="2" name="Image 0" descr="/Users/jeremy/dev/einfach-hausen/.worktrees/t0165-premium/presentation/premium/rendered/slide-11.png">    </p:cNvPr>
+          <p:cNvPr id="2" name="Image 0" descr="/home/ubuntu/dev/einfach-hausen/t0165-prime-redesign/presentation/premium/rendered/slide-11.png">    </p:cNvPr>
           <p:cNvPicPr>
             <a:picLocks noChangeAspect="1"/>
           </p:cNvPicPr>
@@ -2291,7 +2291,7 @@
       </p:grpSpPr>
       <p:pic>
         <p:nvPicPr>
-          <p:cNvPr id="2" name="Image 0" descr="/Users/jeremy/dev/einfach-hausen/.worktrees/t0165-premium/presentation/premium/rendered/slide-12.png">    </p:cNvPr>
+          <p:cNvPr id="2" name="Image 0" descr="/home/ubuntu/dev/einfach-hausen/t0165-prime-redesign/presentation/premium/rendered/slide-12.png">    </p:cNvPr>
           <p:cNvPicPr>
             <a:picLocks noChangeAspect="1"/>
           </p:cNvPicPr>
@@ -2347,7 +2347,7 @@
       </p:grpSpPr>
       <p:pic>
         <p:nvPicPr>
-          <p:cNvPr id="2" name="Image 0" descr="/Users/jeremy/dev/einfach-hausen/.worktrees/t0165-premium/presentation/premium/rendered/slide-13.png">    </p:cNvPr>
+          <p:cNvPr id="2" name="Image 0" descr="/home/ubuntu/dev/einfach-hausen/t0165-prime-redesign/presentation/premium/rendered/slide-13.png">    </p:cNvPr>
           <p:cNvPicPr>
             <a:picLocks noChangeAspect="1"/>
           </p:cNvPicPr>
@@ -2403,7 +2403,7 @@
       </p:grpSpPr>
       <p:pic>
         <p:nvPicPr>
-          <p:cNvPr id="2" name="Image 0" descr="/Users/jeremy/dev/einfach-hausen/.worktrees/t0165-premium/presentation/premium/rendered/slide-14.png">    </p:cNvPr>
+          <p:cNvPr id="2" name="Image 0" descr="/home/ubuntu/dev/einfach-hausen/t0165-prime-redesign/presentation/premium/rendered/slide-14.png">    </p:cNvPr>
           <p:cNvPicPr>
             <a:picLocks noChangeAspect="1"/>
           </p:cNvPicPr>
@@ -2459,7 +2459,7 @@
       </p:grpSpPr>
       <p:pic>
         <p:nvPicPr>
-          <p:cNvPr id="2" name="Image 0" descr="/Users/jeremy/dev/einfach-hausen/.worktrees/t0165-premium/presentation/premium/rendered/slide-15.png">    </p:cNvPr>
+          <p:cNvPr id="2" name="Image 0" descr="/home/ubuntu/dev/einfach-hausen/t0165-prime-redesign/presentation/premium/rendered/slide-15.png">    </p:cNvPr>
           <p:cNvPicPr>
             <a:picLocks noChangeAspect="1"/>
           </p:cNvPicPr>
@@ -2515,7 +2515,7 @@
       </p:grpSpPr>
       <p:pic>
         <p:nvPicPr>
-          <p:cNvPr id="2" name="Image 0" descr="/Users/jeremy/dev/einfach-hausen/.worktrees/t0165-premium/presentation/premium/rendered/slide-02.png">    </p:cNvPr>
+          <p:cNvPr id="2" name="Image 0" descr="/home/ubuntu/dev/einfach-hausen/t0165-prime-redesign/presentation/premium/rendered/slide-02.png">    </p:cNvPr>
           <p:cNvPicPr>
             <a:picLocks noChangeAspect="1"/>
           </p:cNvPicPr>
@@ -2571,7 +2571,7 @@
       </p:grpSpPr>
       <p:pic>
         <p:nvPicPr>
-          <p:cNvPr id="2" name="Image 0" descr="/Users/jeremy/dev/einfach-hausen/.worktrees/t0165-premium/presentation/premium/rendered/slide-03.png">    </p:cNvPr>
+          <p:cNvPr id="2" name="Image 0" descr="/home/ubuntu/dev/einfach-hausen/t0165-prime-redesign/presentation/premium/rendered/slide-03.png">    </p:cNvPr>
           <p:cNvPicPr>
             <a:picLocks noChangeAspect="1"/>
           </p:cNvPicPr>
@@ -2627,7 +2627,7 @@
       </p:grpSpPr>
       <p:pic>
         <p:nvPicPr>
-          <p:cNvPr id="2" name="Image 0" descr="/Users/jeremy/dev/einfach-hausen/.worktrees/t0165-premium/presentation/premium/rendered/slide-04.png">    </p:cNvPr>
+          <p:cNvPr id="2" name="Image 0" descr="/home/ubuntu/dev/einfach-hausen/t0165-prime-redesign/presentation/premium/rendered/slide-04.png">    </p:cNvPr>
           <p:cNvPicPr>
             <a:picLocks noChangeAspect="1"/>
           </p:cNvPicPr>
@@ -2683,7 +2683,7 @@
       </p:grpSpPr>
       <p:pic>
         <p:nvPicPr>
-          <p:cNvPr id="2" name="Image 0" descr="/Users/jeremy/dev/einfach-hausen/.worktrees/t0165-premium/presentation/premium/rendered/slide-05.png">    </p:cNvPr>
+          <p:cNvPr id="2" name="Image 0" descr="/home/ubuntu/dev/einfach-hausen/t0165-prime-redesign/presentation/premium/rendered/slide-05.png">    </p:cNvPr>
           <p:cNvPicPr>
             <a:picLocks noChangeAspect="1"/>
           </p:cNvPicPr>
@@ -2739,7 +2739,7 @@
       </p:grpSpPr>
       <p:pic>
         <p:nvPicPr>
-          <p:cNvPr id="2" name="Image 0" descr="/Users/jeremy/dev/einfach-hausen/.worktrees/t0165-premium/presentation/premium/rendered/slide-06.png">    </p:cNvPr>
+          <p:cNvPr id="2" name="Image 0" descr="/home/ubuntu/dev/einfach-hausen/t0165-prime-redesign/presentation/premium/rendered/slide-06.png">    </p:cNvPr>
           <p:cNvPicPr>
             <a:picLocks noChangeAspect="1"/>
           </p:cNvPicPr>
@@ -2795,7 +2795,7 @@
       </p:grpSpPr>
       <p:pic>
         <p:nvPicPr>
-          <p:cNvPr id="2" name="Image 0" descr="/Users/jeremy/dev/einfach-hausen/.worktrees/t0165-premium/presentation/premium/rendered/slide-07.png">    </p:cNvPr>
+          <p:cNvPr id="2" name="Image 0" descr="/home/ubuntu/dev/einfach-hausen/t0165-prime-redesign/presentation/premium/rendered/slide-07.png">    </p:cNvPr>
           <p:cNvPicPr>
             <a:picLocks noChangeAspect="1"/>
           </p:cNvPicPr>
@@ -2851,7 +2851,7 @@
       </p:grpSpPr>
       <p:pic>
         <p:nvPicPr>
-          <p:cNvPr id="2" name="Image 0" descr="/Users/jeremy/dev/einfach-hausen/.worktrees/t0165-premium/presentation/premium/rendered/slide-08.png">    </p:cNvPr>
+          <p:cNvPr id="2" name="Image 0" descr="/home/ubuntu/dev/einfach-hausen/t0165-prime-redesign/presentation/premium/rendered/slide-08.png">    </p:cNvPr>
           <p:cNvPicPr>
             <a:picLocks noChangeAspect="1"/>
           </p:cNvPicPr>
@@ -2907,7 +2907,7 @@
       </p:grpSpPr>
       <p:pic>
         <p:nvPicPr>
-          <p:cNvPr id="2" name="Image 0" descr="/Users/jeremy/dev/einfach-hausen/.worktrees/t0165-premium/presentation/premium/rendered/slide-09.png">    </p:cNvPr>
+          <p:cNvPr id="2" name="Image 0" descr="/home/ubuntu/dev/einfach-hausen/t0165-prime-redesign/presentation/premium/rendered/slide-09.png">    </p:cNvPr>
           <p:cNvPicPr>
             <a:picLocks noChangeAspect="1"/>
           </p:cNvPicPr>

</xml_diff>

<commit_message>
feat(presentation): align premium deck with app design
</commit_message>
<xml_diff>
--- a/presentation/premium/einfachhausen-premium.pptx
+++ b/presentation/premium/einfachhausen-premium.pptx
@@ -2123,7 +2123,7 @@
       </p:grpSpPr>
       <p:pic>
         <p:nvPicPr>
-          <p:cNvPr id="2" name="Image 0" descr="/home/ubuntu/dev/einfach-hausen/t0165-prime-redesign/presentation/premium/rendered/slide-01.png">    </p:cNvPr>
+          <p:cNvPr id="2" name="Image 0" descr="/home/ubuntu/dev/einfach-hausen-t0165-premium-v3/presentation/premium/slide-01.png">    </p:cNvPr>
           <p:cNvPicPr>
             <a:picLocks noChangeAspect="1"/>
           </p:cNvPicPr>
@@ -2179,7 +2179,7 @@
       </p:grpSpPr>
       <p:pic>
         <p:nvPicPr>
-          <p:cNvPr id="2" name="Image 0" descr="/home/ubuntu/dev/einfach-hausen/t0165-prime-redesign/presentation/premium/rendered/slide-10.png">    </p:cNvPr>
+          <p:cNvPr id="2" name="Image 0" descr="/home/ubuntu/dev/einfach-hausen-t0165-premium-v3/presentation/premium/slide-10.png">    </p:cNvPr>
           <p:cNvPicPr>
             <a:picLocks noChangeAspect="1"/>
           </p:cNvPicPr>
@@ -2235,7 +2235,7 @@
       </p:grpSpPr>
       <p:pic>
         <p:nvPicPr>
-          <p:cNvPr id="2" name="Image 0" descr="/home/ubuntu/dev/einfach-hausen/t0165-prime-redesign/presentation/premium/rendered/slide-11.png">    </p:cNvPr>
+          <p:cNvPr id="2" name="Image 0" descr="/home/ubuntu/dev/einfach-hausen-t0165-premium-v3/presentation/premium/slide-11.png">    </p:cNvPr>
           <p:cNvPicPr>
             <a:picLocks noChangeAspect="1"/>
           </p:cNvPicPr>
@@ -2291,7 +2291,7 @@
       </p:grpSpPr>
       <p:pic>
         <p:nvPicPr>
-          <p:cNvPr id="2" name="Image 0" descr="/home/ubuntu/dev/einfach-hausen/t0165-prime-redesign/presentation/premium/rendered/slide-12.png">    </p:cNvPr>
+          <p:cNvPr id="2" name="Image 0" descr="/home/ubuntu/dev/einfach-hausen-t0165-premium-v3/presentation/premium/slide-12.png">    </p:cNvPr>
           <p:cNvPicPr>
             <a:picLocks noChangeAspect="1"/>
           </p:cNvPicPr>
@@ -2347,7 +2347,7 @@
       </p:grpSpPr>
       <p:pic>
         <p:nvPicPr>
-          <p:cNvPr id="2" name="Image 0" descr="/home/ubuntu/dev/einfach-hausen/t0165-prime-redesign/presentation/premium/rendered/slide-13.png">    </p:cNvPr>
+          <p:cNvPr id="2" name="Image 0" descr="/home/ubuntu/dev/einfach-hausen-t0165-premium-v3/presentation/premium/slide-13.png">    </p:cNvPr>
           <p:cNvPicPr>
             <a:picLocks noChangeAspect="1"/>
           </p:cNvPicPr>
@@ -2403,7 +2403,7 @@
       </p:grpSpPr>
       <p:pic>
         <p:nvPicPr>
-          <p:cNvPr id="2" name="Image 0" descr="/home/ubuntu/dev/einfach-hausen/t0165-prime-redesign/presentation/premium/rendered/slide-14.png">    </p:cNvPr>
+          <p:cNvPr id="2" name="Image 0" descr="/home/ubuntu/dev/einfach-hausen-t0165-premium-v3/presentation/premium/slide-14.png">    </p:cNvPr>
           <p:cNvPicPr>
             <a:picLocks noChangeAspect="1"/>
           </p:cNvPicPr>
@@ -2459,7 +2459,7 @@
       </p:grpSpPr>
       <p:pic>
         <p:nvPicPr>
-          <p:cNvPr id="2" name="Image 0" descr="/home/ubuntu/dev/einfach-hausen/t0165-prime-redesign/presentation/premium/rendered/slide-15.png">    </p:cNvPr>
+          <p:cNvPr id="2" name="Image 0" descr="/home/ubuntu/dev/einfach-hausen-t0165-premium-v3/presentation/premium/slide-15.png">    </p:cNvPr>
           <p:cNvPicPr>
             <a:picLocks noChangeAspect="1"/>
           </p:cNvPicPr>
@@ -2515,7 +2515,7 @@
       </p:grpSpPr>
       <p:pic>
         <p:nvPicPr>
-          <p:cNvPr id="2" name="Image 0" descr="/home/ubuntu/dev/einfach-hausen/t0165-prime-redesign/presentation/premium/rendered/slide-02.png">    </p:cNvPr>
+          <p:cNvPr id="2" name="Image 0" descr="/home/ubuntu/dev/einfach-hausen-t0165-premium-v3/presentation/premium/slide-02.png">    </p:cNvPr>
           <p:cNvPicPr>
             <a:picLocks noChangeAspect="1"/>
           </p:cNvPicPr>
@@ -2571,7 +2571,7 @@
       </p:grpSpPr>
       <p:pic>
         <p:nvPicPr>
-          <p:cNvPr id="2" name="Image 0" descr="/home/ubuntu/dev/einfach-hausen/t0165-prime-redesign/presentation/premium/rendered/slide-03.png">    </p:cNvPr>
+          <p:cNvPr id="2" name="Image 0" descr="/home/ubuntu/dev/einfach-hausen-t0165-premium-v3/presentation/premium/slide-03.png">    </p:cNvPr>
           <p:cNvPicPr>
             <a:picLocks noChangeAspect="1"/>
           </p:cNvPicPr>
@@ -2627,7 +2627,7 @@
       </p:grpSpPr>
       <p:pic>
         <p:nvPicPr>
-          <p:cNvPr id="2" name="Image 0" descr="/home/ubuntu/dev/einfach-hausen/t0165-prime-redesign/presentation/premium/rendered/slide-04.png">    </p:cNvPr>
+          <p:cNvPr id="2" name="Image 0" descr="/home/ubuntu/dev/einfach-hausen-t0165-premium-v3/presentation/premium/slide-04.png">    </p:cNvPr>
           <p:cNvPicPr>
             <a:picLocks noChangeAspect="1"/>
           </p:cNvPicPr>
@@ -2683,7 +2683,7 @@
       </p:grpSpPr>
       <p:pic>
         <p:nvPicPr>
-          <p:cNvPr id="2" name="Image 0" descr="/home/ubuntu/dev/einfach-hausen/t0165-prime-redesign/presentation/premium/rendered/slide-05.png">    </p:cNvPr>
+          <p:cNvPr id="2" name="Image 0" descr="/home/ubuntu/dev/einfach-hausen-t0165-premium-v3/presentation/premium/slide-05.png">    </p:cNvPr>
           <p:cNvPicPr>
             <a:picLocks noChangeAspect="1"/>
           </p:cNvPicPr>
@@ -2739,7 +2739,7 @@
       </p:grpSpPr>
       <p:pic>
         <p:nvPicPr>
-          <p:cNvPr id="2" name="Image 0" descr="/home/ubuntu/dev/einfach-hausen/t0165-prime-redesign/presentation/premium/rendered/slide-06.png">    </p:cNvPr>
+          <p:cNvPr id="2" name="Image 0" descr="/home/ubuntu/dev/einfach-hausen-t0165-premium-v3/presentation/premium/slide-06.png">    </p:cNvPr>
           <p:cNvPicPr>
             <a:picLocks noChangeAspect="1"/>
           </p:cNvPicPr>
@@ -2795,7 +2795,7 @@
       </p:grpSpPr>
       <p:pic>
         <p:nvPicPr>
-          <p:cNvPr id="2" name="Image 0" descr="/home/ubuntu/dev/einfach-hausen/t0165-prime-redesign/presentation/premium/rendered/slide-07.png">    </p:cNvPr>
+          <p:cNvPr id="2" name="Image 0" descr="/home/ubuntu/dev/einfach-hausen-t0165-premium-v3/presentation/premium/slide-07.png">    </p:cNvPr>
           <p:cNvPicPr>
             <a:picLocks noChangeAspect="1"/>
           </p:cNvPicPr>
@@ -2851,7 +2851,7 @@
       </p:grpSpPr>
       <p:pic>
         <p:nvPicPr>
-          <p:cNvPr id="2" name="Image 0" descr="/home/ubuntu/dev/einfach-hausen/t0165-prime-redesign/presentation/premium/rendered/slide-08.png">    </p:cNvPr>
+          <p:cNvPr id="2" name="Image 0" descr="/home/ubuntu/dev/einfach-hausen-t0165-premium-v3/presentation/premium/slide-08.png">    </p:cNvPr>
           <p:cNvPicPr>
             <a:picLocks noChangeAspect="1"/>
           </p:cNvPicPr>
@@ -2907,7 +2907,7 @@
       </p:grpSpPr>
       <p:pic>
         <p:nvPicPr>
-          <p:cNvPr id="2" name="Image 0" descr="/home/ubuntu/dev/einfach-hausen/t0165-prime-redesign/presentation/premium/rendered/slide-09.png">    </p:cNvPr>
+          <p:cNvPr id="2" name="Image 0" descr="/home/ubuntu/dev/einfach-hausen-t0165-premium-v3/presentation/premium/slide-09.png">    </p:cNvPr>
           <p:cNvPicPr>
             <a:picLocks noChangeAspect="1"/>
           </p:cNvPicPr>

</xml_diff>